<commit_message>
Deck polish: single-line headings on slides 6 and 15, right-margin fix
Co-Authored-By: Claude Opus 5 <noreply@anthropic.com>
</commit_message>
<xml_diff>
--- a/docs/Group_Meeting_2026-08-10.pptx
+++ b/docs/Group_Meeting_2026-08-10.pptx
@@ -11129,7 +11129,7 @@
                 <a:ea typeface="Arial" pitchFamily="34" charset="-122"/>
                 <a:cs typeface="Arial" pitchFamily="34" charset="-120"/>
               </a:rPr>
-              <a:t>A hypothesis that was backwards</a:t>
+              <a:t>A backwards hypothesis</a:t>
             </a:r>
             <a:endParaRPr lang="en-US" sz="1600" dirty="0"/>
           </a:p>
@@ -11168,7 +11168,7 @@
                 <a:ea typeface="Arial" pitchFamily="34" charset="-122"/>
                 <a:cs typeface="Arial" pitchFamily="34" charset="-120"/>
               </a:rPr>
-              <a:t>finer patches made the task EASIER</a:t>
+              <a:t>finer patches = an easier task</a:t>
             </a:r>
             <a:endParaRPr lang="en-US" sz="1400" dirty="0"/>
           </a:p>
@@ -28952,7 +28952,7 @@
         <p:spPr>
           <a:xfrm>
             <a:off x="502920" y="1600200"/>
-            <a:ext cx="2670048" cy="1481328"/>
+            <a:ext cx="2615184" cy="1481328"/>
           </a:xfrm>
           <a:prstGeom prst="roundRect">
             <a:avLst>
@@ -29013,7 +29013,7 @@
         <p:spPr>
           <a:xfrm>
             <a:off x="630936" y="2176272"/>
-            <a:ext cx="2414016" cy="804672"/>
+            <a:ext cx="2359152" cy="804672"/>
           </a:xfrm>
           <a:prstGeom prst="rect">
             <a:avLst/>
@@ -29027,12 +29027,12 @@
           <a:p>
             <a:pPr indent="0" marL="0">
               <a:lnSpc>
-                <a:spcPts val="1800"/>
+                <a:spcPts val="1750"/>
               </a:lnSpc>
               <a:buNone/>
             </a:pPr>
             <a:r>
-              <a:rPr lang="en-US" sz="1500" dirty="0">
+              <a:rPr lang="en-US" sz="1450" dirty="0">
                 <a:solidFill>
                   <a:srgbClr val="1A1A1A"/>
                 </a:solidFill>
@@ -29042,17 +29042,17 @@
               </a:rPr>
               <a:t>Water suppression only</a:t>
             </a:r>
-            <a:endParaRPr lang="en-US" sz="1500" dirty="0"/>
+            <a:endParaRPr lang="en-US" sz="1450" dirty="0"/>
           </a:p>
           <a:p>
             <a:pPr indent="0" marL="0">
               <a:lnSpc>
-                <a:spcPts val="1800"/>
+                <a:spcPts val="1750"/>
               </a:lnSpc>
               <a:buNone/>
             </a:pPr>
             <a:r>
-              <a:rPr lang="en-US" sz="1500" dirty="0">
+              <a:rPr lang="en-US" sz="1450" dirty="0">
                 <a:solidFill>
                   <a:srgbClr val="1A1A1A"/>
                 </a:solidFill>
@@ -29062,7 +29062,7 @@
               </a:rPr>
               <a:t>points 62,500–68,000 → 0</a:t>
             </a:r>
-            <a:endParaRPr lang="en-US" sz="1500" dirty="0"/>
+            <a:endParaRPr lang="en-US" sz="1450" dirty="0"/>
           </a:p>
         </p:txBody>
       </p:sp>
@@ -29074,7 +29074,7 @@
         </p:nvSpPr>
         <p:spPr>
           <a:xfrm>
-            <a:off x="3200400" y="2267712"/>
+            <a:off x="3145536" y="2267712"/>
             <a:ext cx="137160" cy="155448"/>
           </a:xfrm>
           <a:prstGeom prst="rightArrow">
@@ -29094,8 +29094,8 @@
         </p:nvSpPr>
         <p:spPr>
           <a:xfrm>
-            <a:off x="3364992" y="1600200"/>
-            <a:ext cx="2670048" cy="1481328"/>
+            <a:off x="3337560" y="1600200"/>
+            <a:ext cx="2615184" cy="1481328"/>
           </a:xfrm>
           <a:prstGeom prst="roundRect">
             <a:avLst>
@@ -29116,7 +29116,7 @@
         </p:nvSpPr>
         <p:spPr>
           <a:xfrm>
-            <a:off x="3493008" y="1737360"/>
+            <a:off x="3465576" y="1737360"/>
             <a:ext cx="914400" cy="402336"/>
           </a:xfrm>
           <a:prstGeom prst="rect">
@@ -29155,8 +29155,8 @@
         </p:nvSpPr>
         <p:spPr>
           <a:xfrm>
-            <a:off x="3493008" y="2176272"/>
-            <a:ext cx="2414016" cy="804672"/>
+            <a:off x="3465576" y="2176272"/>
+            <a:ext cx="2359152" cy="804672"/>
           </a:xfrm>
           <a:prstGeom prst="rect">
             <a:avLst/>
@@ -29170,12 +29170,12 @@
           <a:p>
             <a:pPr indent="0" marL="0">
               <a:lnSpc>
-                <a:spcPts val="1800"/>
+                <a:spcPts val="1750"/>
               </a:lnSpc>
               <a:buNone/>
             </a:pPr>
             <a:r>
-              <a:rPr lang="en-US" sz="1500" dirty="0">
+              <a:rPr lang="en-US" sz="1450" dirty="0">
                 <a:solidFill>
                   <a:srgbClr val="1A1A1A"/>
                 </a:solidFill>
@@ -29185,17 +29185,17 @@
               </a:rPr>
               <a:t>EDTA window skipped</a:t>
             </a:r>
-            <a:endParaRPr lang="en-US" sz="1500" dirty="0"/>
+            <a:endParaRPr lang="en-US" sz="1450" dirty="0"/>
           </a:p>
           <a:p>
             <a:pPr indent="0" marL="0">
               <a:lnSpc>
-                <a:spcPts val="1800"/>
+                <a:spcPts val="1750"/>
               </a:lnSpc>
               <a:buNone/>
             </a:pPr>
             <a:r>
-              <a:rPr lang="en-US" sz="1500" dirty="0">
+              <a:rPr lang="en-US" sz="1450" dirty="0">
                 <a:solidFill>
                   <a:srgbClr val="1A1A1A"/>
                 </a:solidFill>
@@ -29205,7 +29205,7 @@
               </a:rPr>
               <a:t>(left largely untouched)</a:t>
             </a:r>
-            <a:endParaRPr lang="en-US" sz="1500" dirty="0"/>
+            <a:endParaRPr lang="en-US" sz="1450" dirty="0"/>
           </a:p>
         </p:txBody>
       </p:sp>
@@ -29217,7 +29217,7 @@
         </p:nvSpPr>
         <p:spPr>
           <a:xfrm>
-            <a:off x="6062472" y="2267712"/>
+            <a:off x="5980176" y="2267712"/>
             <a:ext cx="137160" cy="155448"/>
           </a:xfrm>
           <a:prstGeom prst="rightArrow">
@@ -29237,8 +29237,8 @@
         </p:nvSpPr>
         <p:spPr>
           <a:xfrm>
-            <a:off x="6227064" y="1600200"/>
-            <a:ext cx="2670048" cy="1481328"/>
+            <a:off x="6172200" y="1600200"/>
+            <a:ext cx="2615184" cy="1481328"/>
           </a:xfrm>
           <a:prstGeom prst="roundRect">
             <a:avLst>
@@ -29259,7 +29259,7 @@
         </p:nvSpPr>
         <p:spPr>
           <a:xfrm>
-            <a:off x="6355080" y="1737360"/>
+            <a:off x="6300216" y="1737360"/>
             <a:ext cx="914400" cy="402336"/>
           </a:xfrm>
           <a:prstGeom prst="rect">
@@ -29298,8 +29298,8 @@
         </p:nvSpPr>
         <p:spPr>
           <a:xfrm>
-            <a:off x="6355080" y="2176272"/>
-            <a:ext cx="2414016" cy="804672"/>
+            <a:off x="6300216" y="2176272"/>
+            <a:ext cx="2359152" cy="804672"/>
           </a:xfrm>
           <a:prstGeom prst="rect">
             <a:avLst/>
@@ -29313,12 +29313,12 @@
           <a:p>
             <a:pPr indent="0" marL="0">
               <a:lnSpc>
-                <a:spcPts val="1800"/>
+                <a:spcPts val="1750"/>
               </a:lnSpc>
               <a:buNone/>
             </a:pPr>
             <a:r>
-              <a:rPr lang="en-US" sz="1500" dirty="0">
+              <a:rPr lang="en-US" sz="1450" dirty="0">
                 <a:solidFill>
                   <a:srgbClr val="1A1A1A"/>
                 </a:solidFill>
@@ -29328,17 +29328,17 @@
               </a:rPr>
               <a:t>Uniform magnitude-based</a:t>
             </a:r>
-            <a:endParaRPr lang="en-US" sz="1500" dirty="0"/>
+            <a:endParaRPr lang="en-US" sz="1450" dirty="0"/>
           </a:p>
           <a:p>
             <a:pPr indent="0" marL="0">
               <a:lnSpc>
-                <a:spcPts val="1800"/>
+                <a:spcPts val="1750"/>
               </a:lnSpc>
               <a:buNone/>
             </a:pPr>
             <a:r>
-              <a:rPr lang="en-US" sz="1500" dirty="0">
+              <a:rPr lang="en-US" sz="1450" dirty="0">
                 <a:solidFill>
                   <a:srgbClr val="1A1A1A"/>
                 </a:solidFill>
@@ -29348,7 +29348,7 @@
               </a:rPr>
               <a:t>EDTA suppression</a:t>
             </a:r>
-            <a:endParaRPr lang="en-US" sz="1500" dirty="0"/>
+            <a:endParaRPr lang="en-US" sz="1450" dirty="0"/>
           </a:p>
         </p:txBody>
       </p:sp>
@@ -29360,7 +29360,7 @@
         </p:nvSpPr>
         <p:spPr>
           <a:xfrm>
-            <a:off x="8924544" y="2267712"/>
+            <a:off x="8814816" y="2267712"/>
             <a:ext cx="137160" cy="155448"/>
           </a:xfrm>
           <a:prstGeom prst="rightArrow">
@@ -29380,8 +29380,8 @@
         </p:nvSpPr>
         <p:spPr>
           <a:xfrm>
-            <a:off x="9089136" y="1600200"/>
-            <a:ext cx="2670048" cy="1481328"/>
+            <a:off x="9006840" y="1600200"/>
+            <a:ext cx="2615184" cy="1481328"/>
           </a:xfrm>
           <a:prstGeom prst="roundRect">
             <a:avLst>
@@ -29402,7 +29402,7 @@
         </p:nvSpPr>
         <p:spPr>
           <a:xfrm>
-            <a:off x="9217152" y="1737360"/>
+            <a:off x="9134856" y="1737360"/>
             <a:ext cx="914400" cy="402336"/>
           </a:xfrm>
           <a:prstGeom prst="rect">
@@ -29441,8 +29441,8 @@
         </p:nvSpPr>
         <p:spPr>
           <a:xfrm>
-            <a:off x="9217152" y="2176272"/>
-            <a:ext cx="2414016" cy="804672"/>
+            <a:off x="9134856" y="2176272"/>
+            <a:ext cx="2359152" cy="804672"/>
           </a:xfrm>
           <a:prstGeom prst="rect">
             <a:avLst/>
@@ -29456,12 +29456,12 @@
           <a:p>
             <a:pPr indent="0" marL="0">
               <a:lnSpc>
-                <a:spcPts val="1800"/>
+                <a:spcPts val="1750"/>
               </a:lnSpc>
               <a:buNone/>
             </a:pPr>
             <a:r>
-              <a:rPr lang="en-US" sz="1500" dirty="0">
+              <a:rPr lang="en-US" sz="1450" dirty="0">
                 <a:solidFill>
                   <a:srgbClr val="1A1A1A"/>
                 </a:solidFill>
@@ -29471,17 +29471,17 @@
               </a:rPr>
               <a:t>EDTA cutoff FIXED to the</a:t>
             </a:r>
-            <a:endParaRPr lang="en-US" sz="1500" dirty="0"/>
+            <a:endParaRPr lang="en-US" sz="1450" dirty="0"/>
           </a:p>
           <a:p>
             <a:pPr indent="0" marL="0">
               <a:lnSpc>
-                <a:spcPts val="1800"/>
+                <a:spcPts val="1750"/>
               </a:lnSpc>
               <a:buNone/>
             </a:pPr>
             <a:r>
-              <a:rPr lang="en-US" sz="1500" dirty="0">
+              <a:rPr lang="en-US" sz="1450" dirty="0">
                 <a:solidFill>
                   <a:srgbClr val="1A1A1A"/>
                 </a:solidFill>
@@ -29491,7 +29491,7 @@
               </a:rPr>
               <a:t>baseline-to-peak midpoint</a:t>
             </a:r>
-            <a:endParaRPr lang="en-US" sz="1500" dirty="0"/>
+            <a:endParaRPr lang="en-US" sz="1450" dirty="0"/>
           </a:p>
         </p:txBody>
       </p:sp>
@@ -29705,7 +29705,7 @@
                 <a:ea typeface="Arial" pitchFamily="34" charset="-122"/>
                 <a:cs typeface="Arial" pitchFamily="34" charset="-120"/>
               </a:rPr>
-              <a:t>…but the version does not matter downstream</a:t>
+              <a:t>…but it does not matter downstream</a:t>
             </a:r>
             <a:endParaRPr lang="en-US" sz="1800" dirty="0"/>
           </a:p>
@@ -29719,8 +29719,8 @@
         </p:nvSpPr>
         <p:spPr>
           <a:xfrm>
-            <a:off x="6492240" y="3877056"/>
-            <a:ext cx="4937760" cy="1792224"/>
+            <a:off x="6492240" y="3913632"/>
+            <a:ext cx="4937760" cy="1737360"/>
           </a:xfrm>
           <a:prstGeom prst="rect">
             <a:avLst/>

</xml_diff>

<commit_message>
Deck spacing pass: uniform figure heights, 0.5in bottom margins
All wide figures are now authored at 11.00 x 4.59in, so every figure slide has
the same geometry: figure 1.50-6.09, caption card 6.20-7.00, giving a real 0.5in
bottom margin where several slides previously sat at 0.29-0.38in with their last
card line flush against the card edge.

Also rebalances slide 9 (1.6in of dead space below the content while the third
card was compressed to three lines) and slide 3 (uneven bullet spacing left vs
right), and opens the sub-0.3in gaps on 17 and 18.

Co-Authored-By: Claude Opus 5 <noreply@anthropic.com>
</commit_message>
<xml_diff>
--- a/docs/Group_Meeting_2026-08-10.pptx
+++ b/docs/Group_Meeting_2026-08-10.pptx
@@ -4042,8 +4042,8 @@
         </p:blipFill>
         <p:spPr>
           <a:xfrm>
-            <a:off x="1051537" y="1417320"/>
-            <a:ext cx="10058446" cy="4343400"/>
+            <a:off x="1057046" y="1371600"/>
+            <a:ext cx="10047428" cy="4197096"/>
           </a:xfrm>
           <a:prstGeom prst="rect">
             <a:avLst/>
@@ -4058,12 +4058,12 @@
         </p:nvSpPr>
         <p:spPr>
           <a:xfrm>
-            <a:off x="502920" y="5815584"/>
-            <a:ext cx="11155680" cy="603504"/>
+            <a:off x="502920" y="5669280"/>
+            <a:ext cx="11155680" cy="731520"/>
           </a:xfrm>
           <a:prstGeom prst="roundRect">
             <a:avLst>
-              <a:gd name="adj" fmla="val 12121"/>
+              <a:gd name="adj" fmla="val 10000"/>
             </a:avLst>
           </a:prstGeom>
           <a:solidFill>
@@ -4080,8 +4080,8 @@
         </p:nvSpPr>
         <p:spPr>
           <a:xfrm>
-            <a:off x="777240" y="5870448"/>
-            <a:ext cx="10607040" cy="512064"/>
+            <a:off x="777240" y="5742432"/>
+            <a:ext cx="10607040" cy="603504"/>
           </a:xfrm>
           <a:prstGeom prst="rect">
             <a:avLst/>
@@ -4100,7 +4100,7 @@
               <a:buNone/>
             </a:pPr>
             <a:r>
-              <a:rPr lang="en-US" sz="1500" dirty="0">
+              <a:rPr lang="en-US" sz="1550" dirty="0">
                 <a:solidFill>
                   <a:srgbClr val="1A1A1A"/>
                 </a:solidFill>
@@ -4110,7 +4110,7 @@
               </a:rPr>
               <a:t>Consistent ordering: masked &gt; jigsaw ≈ joint. Two of the gaps are large (0.14–0.18). Barth and MTBLS326 are effectively ties — half a sample and one sample respectively.</a:t>
             </a:r>
-            <a:endParaRPr lang="en-US" sz="1500" dirty="0"/>
+            <a:endParaRPr lang="en-US" sz="1550" dirty="0"/>
           </a:p>
         </p:txBody>
       </p:sp>
@@ -7270,12 +7270,12 @@
         </p:nvSpPr>
         <p:spPr>
           <a:xfrm>
-            <a:off x="502920" y="5660136"/>
-            <a:ext cx="11155680" cy="777240"/>
+            <a:off x="502920" y="5669280"/>
+            <a:ext cx="11155680" cy="731520"/>
           </a:xfrm>
           <a:prstGeom prst="roundRect">
             <a:avLst>
-              <a:gd name="adj" fmla="val 9412"/>
+              <a:gd name="adj" fmla="val 10000"/>
             </a:avLst>
           </a:prstGeom>
           <a:solidFill>
@@ -7293,7 +7293,7 @@
         <p:spPr>
           <a:xfrm>
             <a:off x="777240" y="5733288"/>
-            <a:ext cx="10607040" cy="640080"/>
+            <a:ext cx="10607040" cy="603504"/>
           </a:xfrm>
           <a:prstGeom prst="rect">
             <a:avLst/>
@@ -10621,12 +10621,12 @@
         </p:nvSpPr>
         <p:spPr>
           <a:xfrm>
-            <a:off x="502920" y="5660136"/>
-            <a:ext cx="5440680" cy="777240"/>
+            <a:off x="502920" y="5669280"/>
+            <a:ext cx="5440680" cy="731520"/>
           </a:xfrm>
           <a:prstGeom prst="roundRect">
             <a:avLst>
-              <a:gd name="adj" fmla="val 9412"/>
+              <a:gd name="adj" fmla="val 10000"/>
             </a:avLst>
           </a:prstGeom>
           <a:solidFill>
@@ -10643,8 +10643,8 @@
         </p:nvSpPr>
         <p:spPr>
           <a:xfrm>
-            <a:off x="731520" y="5715000"/>
-            <a:ext cx="4992624" cy="676656"/>
+            <a:off x="731520" y="5724144"/>
+            <a:ext cx="4992624" cy="621792"/>
           </a:xfrm>
           <a:prstGeom prst="rect">
             <a:avLst/>
@@ -10685,12 +10685,12 @@
         </p:nvSpPr>
         <p:spPr>
           <a:xfrm>
-            <a:off x="6217920" y="5660136"/>
-            <a:ext cx="5440680" cy="777240"/>
+            <a:off x="6217920" y="5669280"/>
+            <a:ext cx="5440680" cy="731520"/>
           </a:xfrm>
           <a:prstGeom prst="roundRect">
             <a:avLst>
-              <a:gd name="adj" fmla="val 9412"/>
+              <a:gd name="adj" fmla="val 10000"/>
             </a:avLst>
           </a:prstGeom>
           <a:solidFill>
@@ -10707,8 +10707,8 @@
         </p:nvSpPr>
         <p:spPr>
           <a:xfrm>
-            <a:off x="6446520" y="5715000"/>
-            <a:ext cx="4992624" cy="676656"/>
+            <a:off x="6446520" y="5724144"/>
+            <a:ext cx="4992624" cy="621792"/>
           </a:xfrm>
           <a:prstGeom prst="rect">
             <a:avLst/>
@@ -14084,7 +14084,7 @@
         </p:nvSpPr>
         <p:spPr>
           <a:xfrm>
-            <a:off x="502920" y="4261104"/>
+            <a:off x="502920" y="4297680"/>
             <a:ext cx="11155680" cy="310896"/>
           </a:xfrm>
           <a:prstGeom prst="rect">
@@ -14123,12 +14123,12 @@
         </p:nvSpPr>
         <p:spPr>
           <a:xfrm>
-            <a:off x="502920" y="4681728"/>
-            <a:ext cx="11155680" cy="1517904"/>
+            <a:off x="502920" y="4773168"/>
+            <a:ext cx="11155680" cy="1444752"/>
           </a:xfrm>
           <a:prstGeom prst="roundRect">
             <a:avLst>
-              <a:gd name="adj" fmla="val 4819"/>
+              <a:gd name="adj" fmla="val 5063"/>
             </a:avLst>
           </a:prstGeom>
           <a:solidFill>
@@ -14145,7 +14145,7 @@
         </p:nvSpPr>
         <p:spPr>
           <a:xfrm>
-            <a:off x="777240" y="4791456"/>
+            <a:off x="777240" y="4864608"/>
             <a:ext cx="7315200" cy="310896"/>
           </a:xfrm>
           <a:prstGeom prst="rect">
@@ -14184,8 +14184,8 @@
         </p:nvSpPr>
         <p:spPr>
           <a:xfrm>
-            <a:off x="777240" y="5120640"/>
-            <a:ext cx="10607040" cy="1005840"/>
+            <a:off x="777240" y="5193792"/>
+            <a:ext cx="10607040" cy="950976"/>
           </a:xfrm>
           <a:prstGeom prst="rect">
             <a:avLst/>
@@ -15023,12 +15023,12 @@
         </p:nvSpPr>
         <p:spPr>
           <a:xfrm>
-            <a:off x="502920" y="5724144"/>
-            <a:ext cx="11155680" cy="640080"/>
+            <a:off x="502920" y="5705856"/>
+            <a:ext cx="11155680" cy="658368"/>
           </a:xfrm>
           <a:prstGeom prst="roundRect">
             <a:avLst>
-              <a:gd name="adj" fmla="val 11429"/>
+              <a:gd name="adj" fmla="val 11111"/>
             </a:avLst>
           </a:prstGeom>
           <a:solidFill>
@@ -15241,8 +15241,8 @@
         </p:blipFill>
         <p:spPr>
           <a:xfrm>
-            <a:off x="1051555" y="1371600"/>
-            <a:ext cx="10058409" cy="4480560"/>
+            <a:off x="1057046" y="1371600"/>
+            <a:ext cx="10047428" cy="4197096"/>
           </a:xfrm>
           <a:prstGeom prst="rect">
             <a:avLst/>
@@ -15257,12 +15257,12 @@
         </p:nvSpPr>
         <p:spPr>
           <a:xfrm>
-            <a:off x="502920" y="5925312"/>
-            <a:ext cx="11155680" cy="658368"/>
+            <a:off x="502920" y="5669280"/>
+            <a:ext cx="11155680" cy="731520"/>
           </a:xfrm>
           <a:prstGeom prst="roundRect">
             <a:avLst>
-              <a:gd name="adj" fmla="val 11111"/>
+              <a:gd name="adj" fmla="val 10000"/>
             </a:avLst>
           </a:prstGeom>
           <a:solidFill>
@@ -15279,8 +15279,8 @@
         </p:nvSpPr>
         <p:spPr>
           <a:xfrm>
-            <a:off x="777240" y="5989320"/>
-            <a:ext cx="10607040" cy="548640"/>
+            <a:off x="777240" y="5742432"/>
+            <a:ext cx="10607040" cy="603504"/>
           </a:xfrm>
           <a:prstGeom prst="rect">
             <a:avLst/>
@@ -15299,7 +15299,7 @@
               <a:buNone/>
             </a:pPr>
             <a:r>
-              <a:rPr lang="en-US" sz="1450" dirty="0">
+              <a:rPr lang="en-US" sz="1550" dirty="0">
                 <a:solidFill>
                   <a:srgbClr val="1A1A1A"/>
                 </a:solidFill>
@@ -15309,7 +15309,7 @@
               </a:rPr>
               <a:t>The 0.888 reference was rank 1 of 5 and sits +1.6 sd above its own distribution. The gap does not shrink — it vanishes and marginally reverses. §5f retracted; experiments #8 and #13 were hunting the mechanism of a non-effect.</a:t>
             </a:r>
-            <a:endParaRPr lang="en-US" sz="1450" dirty="0"/>
+            <a:endParaRPr lang="en-US" sz="1550" dirty="0"/>
           </a:p>
         </p:txBody>
       </p:sp>
@@ -16275,8 +16275,8 @@
         </p:blipFill>
         <p:spPr>
           <a:xfrm>
-            <a:off x="1051555" y="1371600"/>
-            <a:ext cx="10058409" cy="4480560"/>
+            <a:off x="1057046" y="1371600"/>
+            <a:ext cx="10047428" cy="4197096"/>
           </a:xfrm>
           <a:prstGeom prst="rect">
             <a:avLst/>
@@ -16291,12 +16291,12 @@
         </p:nvSpPr>
         <p:spPr>
           <a:xfrm>
-            <a:off x="502920" y="5925312"/>
-            <a:ext cx="5532120" cy="658368"/>
+            <a:off x="502920" y="5669280"/>
+            <a:ext cx="5532120" cy="731520"/>
           </a:xfrm>
           <a:prstGeom prst="roundRect">
             <a:avLst>
-              <a:gd name="adj" fmla="val 11111"/>
+              <a:gd name="adj" fmla="val 10000"/>
             </a:avLst>
           </a:prstGeom>
           <a:solidFill>
@@ -16313,8 +16313,8 @@
         </p:nvSpPr>
         <p:spPr>
           <a:xfrm>
-            <a:off x="731520" y="5980176"/>
-            <a:ext cx="5074920" cy="566928"/>
+            <a:off x="731520" y="5724144"/>
+            <a:ext cx="5074920" cy="621792"/>
           </a:xfrm>
           <a:prstGeom prst="rect">
             <a:avLst/>
@@ -16355,12 +16355,12 @@
         </p:nvSpPr>
         <p:spPr>
           <a:xfrm>
-            <a:off x="6309360" y="5925312"/>
-            <a:ext cx="5349240" cy="658368"/>
+            <a:off x="6309360" y="5669280"/>
+            <a:ext cx="5349240" cy="731520"/>
           </a:xfrm>
           <a:prstGeom prst="roundRect">
             <a:avLst>
-              <a:gd name="adj" fmla="val 11111"/>
+              <a:gd name="adj" fmla="val 10000"/>
             </a:avLst>
           </a:prstGeom>
           <a:solidFill>
@@ -16377,8 +16377,8 @@
         </p:nvSpPr>
         <p:spPr>
           <a:xfrm>
-            <a:off x="6537960" y="5980176"/>
-            <a:ext cx="4892040" cy="566928"/>
+            <a:off x="6537960" y="5724144"/>
+            <a:ext cx="4892040" cy="621792"/>
           </a:xfrm>
           <a:prstGeom prst="rect">
             <a:avLst/>
@@ -17550,12 +17550,12 @@
         </p:nvSpPr>
         <p:spPr>
           <a:xfrm>
-            <a:off x="502920" y="5687568"/>
-            <a:ext cx="11155680" cy="749808"/>
+            <a:off x="502920" y="5696712"/>
+            <a:ext cx="11155680" cy="704088"/>
           </a:xfrm>
           <a:prstGeom prst="roundRect">
             <a:avLst>
-              <a:gd name="adj" fmla="val 9756"/>
+              <a:gd name="adj" fmla="val 10390"/>
             </a:avLst>
           </a:prstGeom>
           <a:solidFill>
@@ -17573,7 +17573,7 @@
         <p:spPr>
           <a:xfrm>
             <a:off x="777240" y="5760720"/>
-            <a:ext cx="10607040" cy="621792"/>
+            <a:ext cx="10607040" cy="585216"/>
           </a:xfrm>
           <a:prstGeom prst="rect">
             <a:avLst/>
@@ -17771,8 +17771,8 @@
         </p:blipFill>
         <p:spPr>
           <a:xfrm>
-            <a:off x="1056710" y="1371600"/>
-            <a:ext cx="10048100" cy="4425696"/>
+            <a:off x="1057046" y="1371600"/>
+            <a:ext cx="10047428" cy="4197096"/>
           </a:xfrm>
           <a:prstGeom prst="rect">
             <a:avLst/>
@@ -17787,12 +17787,12 @@
         </p:nvSpPr>
         <p:spPr>
           <a:xfrm>
-            <a:off x="502920" y="5870448"/>
-            <a:ext cx="5532120" cy="621792"/>
+            <a:off x="502920" y="5669280"/>
+            <a:ext cx="5532120" cy="731520"/>
           </a:xfrm>
           <a:prstGeom prst="roundRect">
             <a:avLst>
-              <a:gd name="adj" fmla="val 11765"/>
+              <a:gd name="adj" fmla="val 10000"/>
             </a:avLst>
           </a:prstGeom>
           <a:solidFill>
@@ -17809,8 +17809,72 @@
         </p:nvSpPr>
         <p:spPr>
           <a:xfrm>
-            <a:off x="731520" y="5916168"/>
-            <a:ext cx="5074920" cy="530352"/>
+            <a:off x="731520" y="5724144"/>
+            <a:ext cx="5074920" cy="621792"/>
+          </a:xfrm>
+          <a:prstGeom prst="rect">
+            <a:avLst/>
+          </a:prstGeom>
+          <a:noFill/>
+          <a:ln/>
+        </p:spPr>
+        <p:txBody>
+          <a:bodyPr wrap="square" lIns="0" tIns="0" rIns="0" bIns="0" rtlCol="0" anchor="ctr"/>
+          <a:lstStyle/>
+          <a:p>
+            <a:pPr indent="0" marL="0">
+              <a:lnSpc>
+                <a:spcPts val="1700"/>
+              </a:lnSpc>
+              <a:buNone/>
+            </a:pPr>
+            <a:r>
+              <a:rPr lang="en-US" sz="1450" dirty="0">
+                <a:solidFill>
+                  <a:srgbClr val="1A1A1A"/>
+                </a:solidFill>
+                <a:latin typeface="Arial" pitchFamily="34" charset="0"/>
+                <a:ea typeface="Arial" pitchFamily="34" charset="-122"/>
+                <a:cs typeface="Arial" pitchFamily="34" charset="-120"/>
+              </a:rPr>
+              <a:t>Pooled across all five targets at 2 labels/class: +0.0012 ± 0.0162, p = 0.74. Dead even. What looked like a low-shot edge is just both methods sitting near chance.</a:t>
+            </a:r>
+            <a:endParaRPr lang="en-US" sz="1450" dirty="0"/>
+          </a:p>
+        </p:txBody>
+      </p:sp>
+      <p:sp>
+        <p:nvSpPr>
+          <p:cNvPr id="8" name="Shape 5"/>
+          <p:cNvSpPr/>
+          <p:nvPr/>
+        </p:nvSpPr>
+        <p:spPr>
+          <a:xfrm>
+            <a:off x="6309360" y="5669280"/>
+            <a:ext cx="5349240" cy="731520"/>
+          </a:xfrm>
+          <a:prstGeom prst="roundRect">
+            <a:avLst>
+              <a:gd name="adj" fmla="val 10000"/>
+            </a:avLst>
+          </a:prstGeom>
+          <a:solidFill>
+            <a:srgbClr val="EEF3F7"/>
+          </a:solidFill>
+          <a:ln/>
+        </p:spPr>
+      </p:sp>
+      <p:sp>
+        <p:nvSpPr>
+          <p:cNvPr id="9" name="Text 6"/>
+          <p:cNvSpPr/>
+          <p:nvPr/>
+        </p:nvSpPr>
+        <p:spPr>
+          <a:xfrm>
+            <a:off x="6537960" y="5724144"/>
+            <a:ext cx="4892040" cy="621792"/>
           </a:xfrm>
           <a:prstGeom prst="rect">
             <a:avLst/>
@@ -17829,7 +17893,7 @@
               <a:buNone/>
             </a:pPr>
             <a:r>
-              <a:rPr lang="en-US" sz="1400" dirty="0">
+              <a:rPr lang="en-US" sz="1450" dirty="0">
                 <a:solidFill>
                   <a:srgbClr val="1A1A1A"/>
                 </a:solidFill>
@@ -17837,73 +17901,9 @@
                 <a:ea typeface="Arial" pitchFamily="34" charset="-122"/>
                 <a:cs typeface="Arial" pitchFamily="34" charset="-120"/>
               </a:rPr>
-              <a:t>Pooled across all five targets at 2 labels/class: +0.0012 ± 0.0162, p = 0.74. Dead even. What looked like a low-shot edge is just both methods sitting near chance.</a:t>
-            </a:r>
-            <a:endParaRPr lang="en-US" sz="1400" dirty="0"/>
-          </a:p>
-        </p:txBody>
-      </p:sp>
-      <p:sp>
-        <p:nvSpPr>
-          <p:cNvPr id="8" name="Shape 5"/>
-          <p:cNvSpPr/>
-          <p:nvPr/>
-        </p:nvSpPr>
-        <p:spPr>
-          <a:xfrm>
-            <a:off x="6309360" y="5870448"/>
-            <a:ext cx="5349240" cy="621792"/>
-          </a:xfrm>
-          <a:prstGeom prst="roundRect">
-            <a:avLst>
-              <a:gd name="adj" fmla="val 11765"/>
-            </a:avLst>
-          </a:prstGeom>
-          <a:solidFill>
-            <a:srgbClr val="EEF3F7"/>
-          </a:solidFill>
-          <a:ln/>
-        </p:spPr>
-      </p:sp>
-      <p:sp>
-        <p:nvSpPr>
-          <p:cNvPr id="9" name="Text 6"/>
-          <p:cNvSpPr/>
-          <p:nvPr/>
-        </p:nvSpPr>
-        <p:spPr>
-          <a:xfrm>
-            <a:off x="6537960" y="5916168"/>
-            <a:ext cx="4892040" cy="530352"/>
-          </a:xfrm>
-          <a:prstGeom prst="rect">
-            <a:avLst/>
-          </a:prstGeom>
-          <a:noFill/>
-          <a:ln/>
-        </p:spPr>
-        <p:txBody>
-          <a:bodyPr wrap="square" lIns="0" tIns="0" rIns="0" bIns="0" rtlCol="0" anchor="ctr"/>
-          <a:lstStyle/>
-          <a:p>
-            <a:pPr indent="0" marL="0">
-              <a:lnSpc>
-                <a:spcPts val="1600"/>
-              </a:lnSpc>
-              <a:buNone/>
-            </a:pPr>
-            <a:r>
-              <a:rPr lang="en-US" sz="1400" dirty="0">
-                <a:solidFill>
-                  <a:srgbClr val="1A1A1A"/>
-                </a:solidFill>
-                <a:latin typeface="Arial" pitchFamily="34" charset="0"/>
-                <a:ea typeface="Arial" pitchFamily="34" charset="-122"/>
-                <a:cs typeface="Arial" pitchFamily="34" charset="-120"/>
-              </a:rPr>
               <a:t>And the deficit WIDENS with more labels (negative trend on 4 of 5) — the opposite of what transfer learning predicts.</a:t>
             </a:r>
-            <a:endParaRPr lang="en-US" sz="1400" dirty="0"/>
+            <a:endParaRPr lang="en-US" sz="1450" dirty="0"/>
           </a:p>
         </p:txBody>
       </p:sp>
@@ -24705,10 +24705,10 @@
           <a:p>
             <a:pPr marL="342900" indent="-342900">
               <a:lnSpc>
-                <a:spcPts val="1850"/>
+                <a:spcPts val="1900"/>
               </a:lnSpc>
               <a:spcAft>
-                <a:spcPts val="900"/>
+                <a:spcPts val="1500"/>
               </a:spcAft>
               <a:buSzPct val="100000"/>
               <a:buChar char="•"/>
@@ -24729,10 +24729,10 @@
           <a:p>
             <a:pPr marL="342900" indent="-342900">
               <a:lnSpc>
-                <a:spcPts val="1850"/>
+                <a:spcPts val="1900"/>
               </a:lnSpc>
               <a:spcAft>
-                <a:spcPts val="900"/>
+                <a:spcPts val="1500"/>
               </a:spcAft>
               <a:buSzPct val="100000"/>
               <a:buChar char="•"/>
@@ -24753,10 +24753,10 @@
           <a:p>
             <a:pPr marL="342900" indent="-342900">
               <a:lnSpc>
-                <a:spcPts val="1850"/>
+                <a:spcPts val="1900"/>
               </a:lnSpc>
               <a:spcAft>
-                <a:spcPts val="900"/>
+                <a:spcPts val="1500"/>
               </a:spcAft>
               <a:buSzPct val="100000"/>
               <a:buChar char="•"/>
@@ -24777,10 +24777,10 @@
           <a:p>
             <a:pPr marL="342900" indent="-342900">
               <a:lnSpc>
-                <a:spcPts val="1850"/>
+                <a:spcPts val="1900"/>
               </a:lnSpc>
               <a:spcAft>
-                <a:spcPts val="900"/>
+                <a:spcPts val="1500"/>
               </a:spcAft>
               <a:buSzPct val="100000"/>
               <a:buChar char="•"/>
@@ -24801,10 +24801,10 @@
           <a:p>
             <a:pPr marL="342900" indent="-342900">
               <a:lnSpc>
-                <a:spcPts val="1850"/>
+                <a:spcPts val="1900"/>
               </a:lnSpc>
               <a:spcAft>
-                <a:spcPts val="900"/>
+                <a:spcPts val="1500"/>
               </a:spcAft>
               <a:buSzPct val="100000"/>
               <a:buChar char="•"/>
@@ -31544,7 +31544,7 @@
         </p:blipFill>
         <p:spPr>
           <a:xfrm>
-            <a:off x="1051651" y="1389888"/>
+            <a:off x="1051651" y="1371600"/>
             <a:ext cx="10058217" cy="3703320"/>
           </a:xfrm>
           <a:prstGeom prst="rect">
@@ -31561,7 +31561,7 @@
         <p:spPr>
           <a:xfrm>
             <a:off x="502920" y="5138928"/>
-            <a:ext cx="11155680" cy="310896"/>
+            <a:ext cx="11155680" cy="292608"/>
           </a:xfrm>
           <a:prstGeom prst="rect">
             <a:avLst/>
@@ -31641,12 +31641,12 @@
         </p:nvSpPr>
         <p:spPr>
           <a:xfrm>
-            <a:off x="502920" y="5504688"/>
-            <a:ext cx="11155680" cy="841248"/>
+            <a:off x="502920" y="5541264"/>
+            <a:ext cx="11155680" cy="859536"/>
           </a:xfrm>
           <a:prstGeom prst="roundRect">
             <a:avLst>
-              <a:gd name="adj" fmla="val 8696"/>
+              <a:gd name="adj" fmla="val 8511"/>
             </a:avLst>
           </a:prstGeom>
           <a:solidFill>
@@ -31663,8 +31663,8 @@
         </p:nvSpPr>
         <p:spPr>
           <a:xfrm>
-            <a:off x="777240" y="5596128"/>
-            <a:ext cx="10607040" cy="676656"/>
+            <a:off x="777240" y="5605272"/>
+            <a:ext cx="10607040" cy="731520"/>
           </a:xfrm>
           <a:prstGeom prst="rect">
             <a:avLst/>
@@ -31871,12 +31871,12 @@
         </p:nvSpPr>
         <p:spPr>
           <a:xfrm>
-            <a:off x="502920" y="1517904"/>
-            <a:ext cx="6766560" cy="1152144"/>
+            <a:off x="502920" y="1481328"/>
+            <a:ext cx="6766560" cy="1316736"/>
           </a:xfrm>
           <a:prstGeom prst="roundRect">
             <a:avLst>
-              <a:gd name="adj" fmla="val 6349"/>
+              <a:gd name="adj" fmla="val 5556"/>
             </a:avLst>
           </a:prstGeom>
           <a:solidFill>
@@ -31893,7 +31893,7 @@
         </p:nvSpPr>
         <p:spPr>
           <a:xfrm>
-            <a:off x="777240" y="1627632"/>
+            <a:off x="777240" y="1609344"/>
             <a:ext cx="6217920" cy="329184"/>
           </a:xfrm>
           <a:prstGeom prst="rect">
@@ -31933,316 +31933,7 @@
         <p:spPr>
           <a:xfrm>
             <a:off x="777240" y="1975104"/>
-            <a:ext cx="6263640" cy="603504"/>
-          </a:xfrm>
-          <a:prstGeom prst="rect">
-            <a:avLst/>
-          </a:prstGeom>
-          <a:noFill/>
-          <a:ln/>
-        </p:spPr>
-        <p:txBody>
-          <a:bodyPr wrap="square" lIns="0" tIns="0" rIns="0" bIns="0" rtlCol="0" anchor="ctr"/>
-          <a:lstStyle/>
-          <a:p>
-            <a:pPr indent="0" marL="0">
-              <a:lnSpc>
-                <a:spcPts val="1850"/>
-              </a:lnSpc>
-              <a:buNone/>
-            </a:pPr>
-            <a:r>
-              <a:rPr lang="en-US" sz="1550" dirty="0">
-                <a:solidFill>
-                  <a:srgbClr val="1A1A1A"/>
-                </a:solidFill>
-                <a:latin typeface="Arial" pitchFamily="34" charset="0"/>
-                <a:ea typeface="Arial" pitchFamily="34" charset="-122"/>
-                <a:cs typeface="Arial" pitchFamily="34" charset="-120"/>
-              </a:rPr>
-              <a:t>Both tracks see exactly the same splits — LOOCV for Barth / MTBLS326, stratified 10-fold (seed 42) for the rest.</a:t>
-            </a:r>
-            <a:endParaRPr lang="en-US" sz="1550" dirty="0"/>
-          </a:p>
-        </p:txBody>
-      </p:sp>
-      <p:sp>
-        <p:nvSpPr>
-          <p:cNvPr id="8" name="Shape 6"/>
-          <p:cNvSpPr/>
-          <p:nvPr/>
-        </p:nvSpPr>
-        <p:spPr>
-          <a:xfrm>
-            <a:off x="502920" y="2834640"/>
-            <a:ext cx="6766560" cy="1152144"/>
-          </a:xfrm>
-          <a:prstGeom prst="roundRect">
-            <a:avLst>
-              <a:gd name="adj" fmla="val 6349"/>
-            </a:avLst>
-          </a:prstGeom>
-          <a:solidFill>
-            <a:srgbClr val="EEF3F7"/>
-          </a:solidFill>
-          <a:ln/>
-        </p:spPr>
-      </p:sp>
-      <p:sp>
-        <p:nvSpPr>
-          <p:cNvPr id="9" name="Text 7"/>
-          <p:cNvSpPr/>
-          <p:nvPr/>
-        </p:nvSpPr>
-        <p:spPr>
-          <a:xfrm>
-            <a:off x="777240" y="2944368"/>
-            <a:ext cx="6217920" cy="329184"/>
-          </a:xfrm>
-          <a:prstGeom prst="rect">
-            <a:avLst/>
-          </a:prstGeom>
-          <a:noFill/>
-          <a:ln/>
-        </p:spPr>
-        <p:txBody>
-          <a:bodyPr wrap="square" lIns="0" tIns="0" rIns="0" bIns="0" rtlCol="0" anchor="ctr"/>
-          <a:lstStyle/>
-          <a:p>
-            <a:pPr indent="0" marL="0">
-              <a:buNone/>
-            </a:pPr>
-            <a:r>
-              <a:rPr lang="en-US" sz="1800" b="1" dirty="0">
-                <a:solidFill>
-                  <a:srgbClr val="065A82"/>
-                </a:solidFill>
-                <a:latin typeface="Arial" pitchFamily="34" charset="0"/>
-                <a:ea typeface="Arial" pitchFamily="34" charset="-122"/>
-                <a:cs typeface="Arial" pitchFamily="34" charset="-120"/>
-              </a:rPr>
-              <a:t>Identical metric</a:t>
-            </a:r>
-            <a:endParaRPr lang="en-US" sz="1800" dirty="0"/>
-          </a:p>
-        </p:txBody>
-      </p:sp>
-      <p:sp>
-        <p:nvSpPr>
-          <p:cNvPr id="10" name="Text 8"/>
-          <p:cNvSpPr/>
-          <p:nvPr/>
-        </p:nvSpPr>
-        <p:spPr>
-          <a:xfrm>
-            <a:off x="777240" y="3291840"/>
-            <a:ext cx="6263640" cy="603504"/>
-          </a:xfrm>
-          <a:prstGeom prst="rect">
-            <a:avLst/>
-          </a:prstGeom>
-          <a:noFill/>
-          <a:ln/>
-        </p:spPr>
-        <p:txBody>
-          <a:bodyPr wrap="square" lIns="0" tIns="0" rIns="0" bIns="0" rtlCol="0" anchor="ctr"/>
-          <a:lstStyle/>
-          <a:p>
-            <a:pPr indent="0" marL="0">
-              <a:lnSpc>
-                <a:spcPts val="1850"/>
-              </a:lnSpc>
-              <a:buNone/>
-            </a:pPr>
-            <a:r>
-              <a:rPr lang="en-US" sz="1550" dirty="0">
-                <a:solidFill>
-                  <a:srgbClr val="1A1A1A"/>
-                </a:solidFill>
-                <a:latin typeface="Arial" pitchFamily="34" charset="0"/>
-                <a:ea typeface="Arial" pitchFamily="34" charset="-122"/>
-                <a:cs typeface="Arial" pitchFamily="34" charset="-120"/>
-              </a:rPr>
-              <a:t>Balanced accuracy everywhere, because several targets are imbalanced (Barth is 14 / 23).</a:t>
-            </a:r>
-            <a:endParaRPr lang="en-US" sz="1550" dirty="0"/>
-          </a:p>
-        </p:txBody>
-      </p:sp>
-      <p:sp>
-        <p:nvSpPr>
-          <p:cNvPr id="11" name="Shape 9"/>
-          <p:cNvSpPr/>
-          <p:nvPr/>
-        </p:nvSpPr>
-        <p:spPr>
-          <a:xfrm>
-            <a:off x="502920" y="4151376"/>
-            <a:ext cx="6766560" cy="1152144"/>
-          </a:xfrm>
-          <a:prstGeom prst="roundRect">
-            <a:avLst>
-              <a:gd name="adj" fmla="val 6349"/>
-            </a:avLst>
-          </a:prstGeom>
-          <a:solidFill>
-            <a:srgbClr val="EEF3F7"/>
-          </a:solidFill>
-          <a:ln/>
-        </p:spPr>
-      </p:sp>
-      <p:sp>
-        <p:nvSpPr>
-          <p:cNvPr id="12" name="Text 10"/>
-          <p:cNvSpPr/>
-          <p:nvPr/>
-        </p:nvSpPr>
-        <p:spPr>
-          <a:xfrm>
-            <a:off x="777240" y="4261104"/>
-            <a:ext cx="6217920" cy="329184"/>
-          </a:xfrm>
-          <a:prstGeom prst="rect">
-            <a:avLst/>
-          </a:prstGeom>
-          <a:noFill/>
-          <a:ln/>
-        </p:spPr>
-        <p:txBody>
-          <a:bodyPr wrap="square" lIns="0" tIns="0" rIns="0" bIns="0" rtlCol="0" anchor="ctr"/>
-          <a:lstStyle/>
-          <a:p>
-            <a:pPr indent="0" marL="0">
-              <a:buNone/>
-            </a:pPr>
-            <a:r>
-              <a:rPr lang="en-US" sz="1800" b="1" dirty="0">
-                <a:solidFill>
-                  <a:srgbClr val="065A82"/>
-                </a:solidFill>
-                <a:latin typeface="Arial" pitchFamily="34" charset="0"/>
-                <a:ea typeface="Arial" pitchFamily="34" charset="-122"/>
-                <a:cs typeface="Arial" pitchFamily="34" charset="-120"/>
-              </a:rPr>
-              <a:t>Both classifiers linear</a:t>
-            </a:r>
-            <a:endParaRPr lang="en-US" sz="1800" dirty="0"/>
-          </a:p>
-        </p:txBody>
-      </p:sp>
-      <p:sp>
-        <p:nvSpPr>
-          <p:cNvPr id="13" name="Text 11"/>
-          <p:cNvSpPr/>
-          <p:nvPr/>
-        </p:nvSpPr>
-        <p:spPr>
-          <a:xfrm>
-            <a:off x="777240" y="4608576"/>
-            <a:ext cx="6263640" cy="603504"/>
-          </a:xfrm>
-          <a:prstGeom prst="rect">
-            <a:avLst/>
-          </a:prstGeom>
-          <a:noFill/>
-          <a:ln/>
-        </p:spPr>
-        <p:txBody>
-          <a:bodyPr wrap="square" lIns="0" tIns="0" rIns="0" bIns="0" rtlCol="0" anchor="ctr"/>
-          <a:lstStyle/>
-          <a:p>
-            <a:pPr indent="0" marL="0">
-              <a:lnSpc>
-                <a:spcPts val="1850"/>
-              </a:lnSpc>
-              <a:buNone/>
-            </a:pPr>
-            <a:r>
-              <a:rPr lang="en-US" sz="1550" dirty="0">
-                <a:solidFill>
-                  <a:srgbClr val="1A1A1A"/>
-                </a:solidFill>
-                <a:latin typeface="Arial" pitchFamily="34" charset="0"/>
-                <a:ea typeface="Arial" pitchFamily="34" charset="-122"/>
-                <a:cs typeface="Arial" pitchFamily="34" charset="-120"/>
-              </a:rPr>
-              <a:t>Classical = StandardScaler → LogReg. SSL = frozen embedding → LogReg probe. So a difference is about the FEATURES, not the classifier.</a:t>
-            </a:r>
-            <a:endParaRPr lang="en-US" sz="1550" dirty="0"/>
-          </a:p>
-        </p:txBody>
-      </p:sp>
-      <p:sp>
-        <p:nvSpPr>
-          <p:cNvPr id="14" name="Shape 12"/>
-          <p:cNvSpPr/>
-          <p:nvPr/>
-        </p:nvSpPr>
-        <p:spPr>
-          <a:xfrm>
-            <a:off x="7543800" y="1517904"/>
-            <a:ext cx="4114800" cy="3877056"/>
-          </a:xfrm>
-          <a:prstGeom prst="roundRect">
-            <a:avLst>
-              <a:gd name="adj" fmla="val 1887"/>
-            </a:avLst>
-          </a:prstGeom>
-          <a:solidFill>
-            <a:srgbClr val="EBF5EE"/>
-          </a:solidFill>
-          <a:ln/>
-        </p:spPr>
-      </p:sp>
-      <p:sp>
-        <p:nvSpPr>
-          <p:cNvPr id="15" name="Text 13"/>
-          <p:cNvSpPr/>
-          <p:nvPr/>
-        </p:nvSpPr>
-        <p:spPr>
-          <a:xfrm>
-            <a:off x="7818120" y="1682496"/>
-            <a:ext cx="3611880" cy="347472"/>
-          </a:xfrm>
-          <a:prstGeom prst="rect">
-            <a:avLst/>
-          </a:prstGeom>
-          <a:noFill/>
-          <a:ln/>
-        </p:spPr>
-        <p:txBody>
-          <a:bodyPr wrap="square" lIns="0" tIns="0" rIns="0" bIns="0" rtlCol="0" anchor="ctr"/>
-          <a:lstStyle/>
-          <a:p>
-            <a:pPr indent="0" marL="0">
-              <a:buNone/>
-            </a:pPr>
-            <a:r>
-              <a:rPr lang="en-US" sz="1900" b="1" dirty="0">
-                <a:solidFill>
-                  <a:srgbClr val="1A7A3C"/>
-                </a:solidFill>
-                <a:latin typeface="Arial" pitchFamily="34" charset="0"/>
-                <a:ea typeface="Arial" pitchFamily="34" charset="-122"/>
-                <a:cs typeface="Arial" pitchFamily="34" charset="-120"/>
-              </a:rPr>
-              <a:t>The validation gate</a:t>
-            </a:r>
-            <a:endParaRPr lang="en-US" sz="1900" dirty="0"/>
-          </a:p>
-        </p:txBody>
-      </p:sp>
-      <p:sp>
-        <p:nvSpPr>
-          <p:cNvPr id="16" name="Text 14"/>
-          <p:cNvSpPr/>
-          <p:nvPr/>
-        </p:nvSpPr>
-        <p:spPr>
-          <a:xfrm>
-            <a:off x="7818120" y="2066544"/>
-            <a:ext cx="3611880" cy="914400"/>
+            <a:ext cx="6263640" cy="749808"/>
           </a:xfrm>
           <a:prstGeom prst="rect">
             <a:avLst/>
@@ -32269,7 +31960,7 @@
                 <a:ea typeface="Arial" pitchFamily="34" charset="-122"/>
                 <a:cs typeface="Arial" pitchFamily="34" charset="-120"/>
               </a:rPr>
-              <a:t>Before drawing any conclusion, the harness had to reproduce the committed classical numbers to 6 decimal places on all five targets:</a:t>
+              <a:t>Both tracks see exactly the same splits — LOOCV for Barth / MTBLS326, stratified 10-fold (seed 42) for the rest.</a:t>
             </a:r>
             <a:endParaRPr lang="en-US" sz="1550" dirty="0"/>
           </a:p>
@@ -32277,14 +31968,75 @@
       </p:sp>
       <p:sp>
         <p:nvSpPr>
-          <p:cNvPr id="17" name="Text 15"/>
-          <p:cNvSpPr/>
-          <p:nvPr/>
-        </p:nvSpPr>
-        <p:spPr>
-          <a:xfrm>
-            <a:off x="7818120" y="3017520"/>
-            <a:ext cx="2103120" cy="1463040"/>
+          <p:cNvPr id="8" name="Shape 6"/>
+          <p:cNvSpPr/>
+          <p:nvPr/>
+        </p:nvSpPr>
+        <p:spPr>
+          <a:xfrm>
+            <a:off x="502920" y="2962656"/>
+            <a:ext cx="6766560" cy="1316736"/>
+          </a:xfrm>
+          <a:prstGeom prst="roundRect">
+            <a:avLst>
+              <a:gd name="adj" fmla="val 5556"/>
+            </a:avLst>
+          </a:prstGeom>
+          <a:solidFill>
+            <a:srgbClr val="EEF3F7"/>
+          </a:solidFill>
+          <a:ln/>
+        </p:spPr>
+      </p:sp>
+      <p:sp>
+        <p:nvSpPr>
+          <p:cNvPr id="9" name="Text 7"/>
+          <p:cNvSpPr/>
+          <p:nvPr/>
+        </p:nvSpPr>
+        <p:spPr>
+          <a:xfrm>
+            <a:off x="777240" y="3090672"/>
+            <a:ext cx="6217920" cy="329184"/>
+          </a:xfrm>
+          <a:prstGeom prst="rect">
+            <a:avLst/>
+          </a:prstGeom>
+          <a:noFill/>
+          <a:ln/>
+        </p:spPr>
+        <p:txBody>
+          <a:bodyPr wrap="square" lIns="0" tIns="0" rIns="0" bIns="0" rtlCol="0" anchor="ctr"/>
+          <a:lstStyle/>
+          <a:p>
+            <a:pPr indent="0" marL="0">
+              <a:buNone/>
+            </a:pPr>
+            <a:r>
+              <a:rPr lang="en-US" sz="1800" b="1" dirty="0">
+                <a:solidFill>
+                  <a:srgbClr val="065A82"/>
+                </a:solidFill>
+                <a:latin typeface="Arial" pitchFamily="34" charset="0"/>
+                <a:ea typeface="Arial" pitchFamily="34" charset="-122"/>
+                <a:cs typeface="Arial" pitchFamily="34" charset="-120"/>
+              </a:rPr>
+              <a:t>Identical metric</a:t>
+            </a:r>
+            <a:endParaRPr lang="en-US" sz="1800" dirty="0"/>
+          </a:p>
+        </p:txBody>
+      </p:sp>
+      <p:sp>
+        <p:nvSpPr>
+          <p:cNvPr id="10" name="Text 8"/>
+          <p:cNvSpPr/>
+          <p:nvPr/>
+        </p:nvSpPr>
+        <p:spPr>
+          <a:xfrm>
+            <a:off x="777240" y="3456432"/>
+            <a:ext cx="6263640" cy="749808"/>
           </a:xfrm>
           <a:prstGeom prst="rect">
             <a:avLst/>
@@ -32298,67 +32050,255 @@
           <a:p>
             <a:pPr indent="0" marL="0">
               <a:lnSpc>
-                <a:spcPts val="2200"/>
+                <a:spcPts val="1900"/>
               </a:lnSpc>
               <a:buNone/>
             </a:pPr>
             <a:r>
-              <a:rPr lang="en-US" sz="1500" dirty="0">
-                <a:solidFill>
-                  <a:srgbClr val="21295C"/>
-                </a:solidFill>
-                <a:latin typeface="Arial" pitchFamily="34" charset="0"/>
-                <a:ea typeface="Arial" pitchFamily="34" charset="-122"/>
-                <a:cs typeface="Arial" pitchFamily="34" charset="-120"/>
-              </a:rPr>
-              <a:t>BrC-T2D cancer</a:t>
-            </a:r>
-            <a:endParaRPr lang="en-US" sz="1500" dirty="0"/>
-          </a:p>
+              <a:rPr lang="en-US" sz="1550" dirty="0">
+                <a:solidFill>
+                  <a:srgbClr val="1A1A1A"/>
+                </a:solidFill>
+                <a:latin typeface="Arial" pitchFamily="34" charset="0"/>
+                <a:ea typeface="Arial" pitchFamily="34" charset="-122"/>
+                <a:cs typeface="Arial" pitchFamily="34" charset="-120"/>
+              </a:rPr>
+              <a:t>Balanced accuracy everywhere, because several targets are imbalanced (Barth is 14 / 23).</a:t>
+            </a:r>
+            <a:endParaRPr lang="en-US" sz="1550" dirty="0"/>
+          </a:p>
+        </p:txBody>
+      </p:sp>
+      <p:sp>
+        <p:nvSpPr>
+          <p:cNvPr id="11" name="Shape 9"/>
+          <p:cNvSpPr/>
+          <p:nvPr/>
+        </p:nvSpPr>
+        <p:spPr>
+          <a:xfrm>
+            <a:off x="502920" y="4443984"/>
+            <a:ext cx="6766560" cy="1316736"/>
+          </a:xfrm>
+          <a:prstGeom prst="roundRect">
+            <a:avLst>
+              <a:gd name="adj" fmla="val 5556"/>
+            </a:avLst>
+          </a:prstGeom>
+          <a:solidFill>
+            <a:srgbClr val="EEF3F7"/>
+          </a:solidFill>
+          <a:ln/>
+        </p:spPr>
+      </p:sp>
+      <p:sp>
+        <p:nvSpPr>
+          <p:cNvPr id="12" name="Text 10"/>
+          <p:cNvSpPr/>
+          <p:nvPr/>
+        </p:nvSpPr>
+        <p:spPr>
+          <a:xfrm>
+            <a:off x="777240" y="4572000"/>
+            <a:ext cx="6217920" cy="329184"/>
+          </a:xfrm>
+          <a:prstGeom prst="rect">
+            <a:avLst/>
+          </a:prstGeom>
+          <a:noFill/>
+          <a:ln/>
+        </p:spPr>
+        <p:txBody>
+          <a:bodyPr wrap="square" lIns="0" tIns="0" rIns="0" bIns="0" rtlCol="0" anchor="ctr"/>
+          <a:lstStyle/>
+          <a:p>
+            <a:pPr indent="0" marL="0">
+              <a:buNone/>
+            </a:pPr>
+            <a:r>
+              <a:rPr lang="en-US" sz="1800" b="1" dirty="0">
+                <a:solidFill>
+                  <a:srgbClr val="065A82"/>
+                </a:solidFill>
+                <a:latin typeface="Arial" pitchFamily="34" charset="0"/>
+                <a:ea typeface="Arial" pitchFamily="34" charset="-122"/>
+                <a:cs typeface="Arial" pitchFamily="34" charset="-120"/>
+              </a:rPr>
+              <a:t>Both classifiers linear</a:t>
+            </a:r>
+            <a:endParaRPr lang="en-US" sz="1800" dirty="0"/>
+          </a:p>
+        </p:txBody>
+      </p:sp>
+      <p:sp>
+        <p:nvSpPr>
+          <p:cNvPr id="13" name="Text 11"/>
+          <p:cNvSpPr/>
+          <p:nvPr/>
+        </p:nvSpPr>
+        <p:spPr>
+          <a:xfrm>
+            <a:off x="777240" y="4937760"/>
+            <a:ext cx="6263640" cy="749808"/>
+          </a:xfrm>
+          <a:prstGeom prst="rect">
+            <a:avLst/>
+          </a:prstGeom>
+          <a:noFill/>
+          <a:ln/>
+        </p:spPr>
+        <p:txBody>
+          <a:bodyPr wrap="square" lIns="0" tIns="0" rIns="0" bIns="0" rtlCol="0" anchor="ctr"/>
+          <a:lstStyle/>
           <a:p>
             <a:pPr indent="0" marL="0">
               <a:lnSpc>
-                <a:spcPts val="2200"/>
+                <a:spcPts val="1900"/>
               </a:lnSpc>
               <a:buNone/>
             </a:pPr>
             <a:r>
-              <a:rPr lang="en-US" sz="1500" dirty="0">
-                <a:solidFill>
-                  <a:srgbClr val="21295C"/>
-                </a:solidFill>
-                <a:latin typeface="Arial" pitchFamily="34" charset="0"/>
-                <a:ea typeface="Arial" pitchFamily="34" charset="-122"/>
-                <a:cs typeface="Arial" pitchFamily="34" charset="-120"/>
-              </a:rPr>
-              <a:t>BrC-T2D diabetes</a:t>
-            </a:r>
-            <a:endParaRPr lang="en-US" sz="1500" dirty="0"/>
-          </a:p>
+              <a:rPr lang="en-US" sz="1550" dirty="0">
+                <a:solidFill>
+                  <a:srgbClr val="1A1A1A"/>
+                </a:solidFill>
+                <a:latin typeface="Arial" pitchFamily="34" charset="0"/>
+                <a:ea typeface="Arial" pitchFamily="34" charset="-122"/>
+                <a:cs typeface="Arial" pitchFamily="34" charset="-120"/>
+              </a:rPr>
+              <a:t>Classical = StandardScaler → LogReg. SSL = frozen embedding → LogReg probe. So a difference is about the FEATURES, not the classifier.</a:t>
+            </a:r>
+            <a:endParaRPr lang="en-US" sz="1550" dirty="0"/>
+          </a:p>
+        </p:txBody>
+      </p:sp>
+      <p:sp>
+        <p:nvSpPr>
+          <p:cNvPr id="14" name="Shape 12"/>
+          <p:cNvSpPr/>
+          <p:nvPr/>
+        </p:nvSpPr>
+        <p:spPr>
+          <a:xfrm>
+            <a:off x="7543800" y="1481328"/>
+            <a:ext cx="4114800" cy="4443984"/>
+          </a:xfrm>
+          <a:prstGeom prst="roundRect">
+            <a:avLst>
+              <a:gd name="adj" fmla="val 1778"/>
+            </a:avLst>
+          </a:prstGeom>
+          <a:solidFill>
+            <a:srgbClr val="EBF5EE"/>
+          </a:solidFill>
+          <a:ln/>
+        </p:spPr>
+      </p:sp>
+      <p:sp>
+        <p:nvSpPr>
+          <p:cNvPr id="15" name="Text 13"/>
+          <p:cNvSpPr/>
+          <p:nvPr/>
+        </p:nvSpPr>
+        <p:spPr>
+          <a:xfrm>
+            <a:off x="7818120" y="1645920"/>
+            <a:ext cx="3611880" cy="347472"/>
+          </a:xfrm>
+          <a:prstGeom prst="rect">
+            <a:avLst/>
+          </a:prstGeom>
+          <a:noFill/>
+          <a:ln/>
+        </p:spPr>
+        <p:txBody>
+          <a:bodyPr wrap="square" lIns="0" tIns="0" rIns="0" bIns="0" rtlCol="0" anchor="ctr"/>
+          <a:lstStyle/>
+          <a:p>
+            <a:pPr indent="0" marL="0">
+              <a:buNone/>
+            </a:pPr>
+            <a:r>
+              <a:rPr lang="en-US" sz="1900" b="1" dirty="0">
+                <a:solidFill>
+                  <a:srgbClr val="1A7A3C"/>
+                </a:solidFill>
+                <a:latin typeface="Arial" pitchFamily="34" charset="0"/>
+                <a:ea typeface="Arial" pitchFamily="34" charset="-122"/>
+                <a:cs typeface="Arial" pitchFamily="34" charset="-120"/>
+              </a:rPr>
+              <a:t>The validation gate</a:t>
+            </a:r>
+            <a:endParaRPr lang="en-US" sz="1900" dirty="0"/>
+          </a:p>
+        </p:txBody>
+      </p:sp>
+      <p:sp>
+        <p:nvSpPr>
+          <p:cNvPr id="16" name="Text 14"/>
+          <p:cNvSpPr/>
+          <p:nvPr/>
+        </p:nvSpPr>
+        <p:spPr>
+          <a:xfrm>
+            <a:off x="7818120" y="2048256"/>
+            <a:ext cx="3611880" cy="960120"/>
+          </a:xfrm>
+          <a:prstGeom prst="rect">
+            <a:avLst/>
+          </a:prstGeom>
+          <a:noFill/>
+          <a:ln/>
+        </p:spPr>
+        <p:txBody>
+          <a:bodyPr wrap="square" lIns="0" tIns="0" rIns="0" bIns="0" rtlCol="0" anchor="ctr"/>
+          <a:lstStyle/>
           <a:p>
             <a:pPr indent="0" marL="0">
               <a:lnSpc>
-                <a:spcPts val="2200"/>
+                <a:spcPts val="1900"/>
               </a:lnSpc>
               <a:buNone/>
             </a:pPr>
             <a:r>
-              <a:rPr lang="en-US" sz="1500" dirty="0">
-                <a:solidFill>
-                  <a:srgbClr val="21295C"/>
-                </a:solidFill>
-                <a:latin typeface="Arial" pitchFamily="34" charset="0"/>
-                <a:ea typeface="Arial" pitchFamily="34" charset="-122"/>
-                <a:cs typeface="Arial" pitchFamily="34" charset="-120"/>
-              </a:rPr>
-              <a:t>MTBLS563</a:t>
-            </a:r>
-            <a:endParaRPr lang="en-US" sz="1500" dirty="0"/>
-          </a:p>
+              <a:rPr lang="en-US" sz="1550" dirty="0">
+                <a:solidFill>
+                  <a:srgbClr val="1A1A1A"/>
+                </a:solidFill>
+                <a:latin typeface="Arial" pitchFamily="34" charset="0"/>
+                <a:ea typeface="Arial" pitchFamily="34" charset="-122"/>
+                <a:cs typeface="Arial" pitchFamily="34" charset="-120"/>
+              </a:rPr>
+              <a:t>Before drawing any conclusion, the harness had to reproduce the committed classical numbers to 6 decimal places on all five targets:</a:t>
+            </a:r>
+            <a:endParaRPr lang="en-US" sz="1550" dirty="0"/>
+          </a:p>
+        </p:txBody>
+      </p:sp>
+      <p:sp>
+        <p:nvSpPr>
+          <p:cNvPr id="17" name="Text 15"/>
+          <p:cNvSpPr/>
+          <p:nvPr/>
+        </p:nvSpPr>
+        <p:spPr>
+          <a:xfrm>
+            <a:off x="7818120" y="3127248"/>
+            <a:ext cx="2103120" cy="1600200"/>
+          </a:xfrm>
+          <a:prstGeom prst="rect">
+            <a:avLst/>
+          </a:prstGeom>
+          <a:noFill/>
+          <a:ln/>
+        </p:spPr>
+        <p:txBody>
+          <a:bodyPr wrap="square" lIns="0" tIns="0" rIns="0" bIns="0" rtlCol="0" anchor="ctr"/>
+          <a:lstStyle/>
           <a:p>
             <a:pPr indent="0" marL="0">
               <a:lnSpc>
-                <a:spcPts val="2200"/>
+                <a:spcPts val="2400"/>
               </a:lnSpc>
               <a:buNone/>
             </a:pPr>
@@ -32371,14 +32311,14 @@
                 <a:ea typeface="Arial" pitchFamily="34" charset="-122"/>
                 <a:cs typeface="Arial" pitchFamily="34" charset="-120"/>
               </a:rPr>
-              <a:t>MTBLS326</a:t>
+              <a:t>BrC-T2D cancer</a:t>
             </a:r>
             <a:endParaRPr lang="en-US" sz="1500" dirty="0"/>
           </a:p>
           <a:p>
             <a:pPr indent="0" marL="0">
               <a:lnSpc>
-                <a:spcPts val="2200"/>
+                <a:spcPts val="2400"/>
               </a:lnSpc>
               <a:buNone/>
             </a:pPr>
@@ -32391,6 +32331,66 @@
                 <a:ea typeface="Arial" pitchFamily="34" charset="-122"/>
                 <a:cs typeface="Arial" pitchFamily="34" charset="-120"/>
               </a:rPr>
+              <a:t>BrC-T2D diabetes</a:t>
+            </a:r>
+            <a:endParaRPr lang="en-US" sz="1500" dirty="0"/>
+          </a:p>
+          <a:p>
+            <a:pPr indent="0" marL="0">
+              <a:lnSpc>
+                <a:spcPts val="2400"/>
+              </a:lnSpc>
+              <a:buNone/>
+            </a:pPr>
+            <a:r>
+              <a:rPr lang="en-US" sz="1500" dirty="0">
+                <a:solidFill>
+                  <a:srgbClr val="21295C"/>
+                </a:solidFill>
+                <a:latin typeface="Arial" pitchFamily="34" charset="0"/>
+                <a:ea typeface="Arial" pitchFamily="34" charset="-122"/>
+                <a:cs typeface="Arial" pitchFamily="34" charset="-120"/>
+              </a:rPr>
+              <a:t>MTBLS563</a:t>
+            </a:r>
+            <a:endParaRPr lang="en-US" sz="1500" dirty="0"/>
+          </a:p>
+          <a:p>
+            <a:pPr indent="0" marL="0">
+              <a:lnSpc>
+                <a:spcPts val="2400"/>
+              </a:lnSpc>
+              <a:buNone/>
+            </a:pPr>
+            <a:r>
+              <a:rPr lang="en-US" sz="1500" dirty="0">
+                <a:solidFill>
+                  <a:srgbClr val="21295C"/>
+                </a:solidFill>
+                <a:latin typeface="Arial" pitchFamily="34" charset="0"/>
+                <a:ea typeface="Arial" pitchFamily="34" charset="-122"/>
+                <a:cs typeface="Arial" pitchFamily="34" charset="-120"/>
+              </a:rPr>
+              <a:t>MTBLS326</a:t>
+            </a:r>
+            <a:endParaRPr lang="en-US" sz="1500" dirty="0"/>
+          </a:p>
+          <a:p>
+            <a:pPr indent="0" marL="0">
+              <a:lnSpc>
+                <a:spcPts val="2400"/>
+              </a:lnSpc>
+              <a:buNone/>
+            </a:pPr>
+            <a:r>
+              <a:rPr lang="en-US" sz="1500" dirty="0">
+                <a:solidFill>
+                  <a:srgbClr val="21295C"/>
+                </a:solidFill>
+                <a:latin typeface="Arial" pitchFamily="34" charset="0"/>
+                <a:ea typeface="Arial" pitchFamily="34" charset="-122"/>
+                <a:cs typeface="Arial" pitchFamily="34" charset="-120"/>
+              </a:rPr>
               <a:t>Barth</a:t>
             </a:r>
             <a:endParaRPr lang="en-US" sz="1500" dirty="0"/>
@@ -32405,8 +32405,8 @@
         </p:nvSpPr>
         <p:spPr>
           <a:xfrm>
-            <a:off x="9921240" y="3017520"/>
-            <a:ext cx="1508760" cy="1463040"/>
+            <a:off x="9921240" y="3127248"/>
+            <a:ext cx="1508760" cy="1600200"/>
           </a:xfrm>
           <a:prstGeom prst="rect">
             <a:avLst/>
@@ -32527,8 +32527,8 @@
         </p:nvSpPr>
         <p:spPr>
           <a:xfrm>
-            <a:off x="7818120" y="4590288"/>
-            <a:ext cx="3611880" cy="658368"/>
+            <a:off x="7818120" y="4864608"/>
+            <a:ext cx="3611880" cy="914400"/>
           </a:xfrm>
           <a:prstGeom prst="rect">
             <a:avLst/>

</xml_diff>

<commit_message>
Final QA pass: legend off the data on slide 8, card padding, gap fixes
Slide 8's in-axes legend was covering a yellow masked band (obscuring the data
the slide is about) -- moved below the axes, and February's r=0.999 caveat folded
into the trap card so the caption stays one line. Also: card bottom padding on
6/21/26, sd captions clear of the shaded band on 19, and the sub-0.3in gaps on
11/25/29.

Co-Authored-By: Claude Opus 5 <noreply@anthropic.com>
</commit_message>
<xml_diff>
--- a/docs/Group_Meeting_2026-08-10.pptx
+++ b/docs/Group_Meeting_2026-08-10.pptx
@@ -7055,8 +7055,8 @@
         </p:nvSpPr>
         <p:spPr>
           <a:xfrm>
-            <a:off x="502920" y="5870448"/>
-            <a:ext cx="11155680" cy="512064"/>
+            <a:off x="502920" y="5961888"/>
+            <a:ext cx="11155680" cy="475488"/>
           </a:xfrm>
           <a:prstGeom prst="rect">
             <a:avLst/>
@@ -16629,8 +16629,8 @@
         </p:nvSpPr>
         <p:spPr>
           <a:xfrm>
-            <a:off x="777240" y="1993392"/>
-            <a:ext cx="4937760" cy="1325880"/>
+            <a:off x="777240" y="1956816"/>
+            <a:ext cx="4937760" cy="1371600"/>
           </a:xfrm>
           <a:prstGeom prst="rect">
             <a:avLst/>
@@ -16644,12 +16644,12 @@
           <a:p>
             <a:pPr indent="0" marL="0">
               <a:lnSpc>
-                <a:spcPts val="1900"/>
+                <a:spcPts val="1800"/>
               </a:lnSpc>
               <a:buNone/>
             </a:pPr>
             <a:r>
-              <a:rPr lang="en-US" sz="1550" dirty="0">
+              <a:rPr lang="en-US" sz="1500" dirty="0">
                 <a:solidFill>
                   <a:srgbClr val="1A1A1A"/>
                 </a:solidFill>
@@ -16659,7 +16659,7 @@
               </a:rPr>
               <a:t>Training writes a "best so far" checkpoint continuously. Evaluate one mid-run and you get a real-looking number for a model that was still training. It happened three times — including once when I claimed --seed was broken on GPU, because I compared a mid-training checkpoint against a finished one.</a:t>
             </a:r>
-            <a:endParaRPr lang="en-US" sz="1550" dirty="0"/>
+            <a:endParaRPr lang="en-US" sz="1500" dirty="0"/>
           </a:p>
         </p:txBody>
       </p:sp>
@@ -18188,7 +18188,7 @@
                 <a:gridCol w="1051560"/>
                 <a:gridCol w="1051560"/>
               </a:tblGrid>
-              <a:tr h="306324">
+              <a:tr h="288036">
                 <a:tc>
                   <a:txBody>
                     <a:bodyPr/>
@@ -18614,7 +18614,7 @@
                   </a:tcPr>
                 </a:tc>
               </a:tr>
-              <a:tr h="306324">
+              <a:tr h="288036">
                 <a:tc>
                   <a:txBody>
                     <a:bodyPr/>
@@ -18956,7 +18956,7 @@
                   </a:tcPr>
                 </a:tc>
               </a:tr>
-              <a:tr h="306324">
+              <a:tr h="288036">
                 <a:tc>
                   <a:txBody>
                     <a:bodyPr/>
@@ -19298,7 +19298,7 @@
                   </a:tcPr>
                 </a:tc>
               </a:tr>
-              <a:tr h="306324">
+              <a:tr h="288036">
                 <a:tc>
                   <a:txBody>
                     <a:bodyPr/>
@@ -19640,7 +19640,7 @@
                   </a:tcPr>
                 </a:tc>
               </a:tr>
-              <a:tr h="306324">
+              <a:tr h="288036">
                 <a:tc>
                   <a:txBody>
                     <a:bodyPr/>
@@ -19982,7 +19982,7 @@
                   </a:tcPr>
                 </a:tc>
               </a:tr>
-              <a:tr h="306324">
+              <a:tr h="288036">
                 <a:tc>
                   <a:txBody>
                     <a:bodyPr/>
@@ -20324,7 +20324,7 @@
                   </a:tcPr>
                 </a:tc>
               </a:tr>
-              <a:tr h="306324">
+              <a:tr h="288036">
                 <a:tc>
                   <a:txBody>
                     <a:bodyPr/>
@@ -20678,12 +20678,12 @@
         </p:nvSpPr>
         <p:spPr>
           <a:xfrm>
-            <a:off x="502920" y="4133088"/>
-            <a:ext cx="11155680" cy="1078992"/>
+            <a:off x="502920" y="4169664"/>
+            <a:ext cx="11155680" cy="1060704"/>
           </a:xfrm>
           <a:prstGeom prst="roundRect">
             <a:avLst>
-              <a:gd name="adj" fmla="val 6780"/>
+              <a:gd name="adj" fmla="val 6897"/>
             </a:avLst>
           </a:prstGeom>
           <a:solidFill>
@@ -20700,7 +20700,7 @@
         </p:nvSpPr>
         <p:spPr>
           <a:xfrm>
-            <a:off x="777240" y="4233672"/>
+            <a:off x="777240" y="4261104"/>
             <a:ext cx="10607040" cy="310896"/>
           </a:xfrm>
           <a:prstGeom prst="rect">
@@ -20739,7 +20739,7 @@
         </p:nvSpPr>
         <p:spPr>
           <a:xfrm>
-            <a:off x="777240" y="4562856"/>
+            <a:off x="777240" y="4590288"/>
             <a:ext cx="10607040" cy="585216"/>
           </a:xfrm>
           <a:prstGeom prst="rect">
@@ -22423,8 +22423,8 @@
         </p:nvSpPr>
         <p:spPr>
           <a:xfrm>
-            <a:off x="777240" y="5833872"/>
-            <a:ext cx="10607040" cy="512064"/>
+            <a:off x="777240" y="5760720"/>
+            <a:ext cx="10607040" cy="658368"/>
           </a:xfrm>
           <a:prstGeom prst="rect">
             <a:avLst/>
@@ -22440,7 +22440,7 @@
               <a:buNone/>
             </a:pPr>
             <a:r>
-              <a:rPr lang="en-US" sz="1650" b="1" dirty="0">
+              <a:rPr lang="en-US" sz="1600" b="1" dirty="0">
                 <a:solidFill>
                   <a:srgbClr val="FFFFFF"/>
                 </a:solidFill>
@@ -22450,7 +22450,7 @@
               </a:rPr>
               <a:t>The pattern: every surviving result is PAIRED — one fixed checkpoint, one thing varied. Every retracted result compared two separately-trained networks.</a:t>
             </a:r>
-            <a:endParaRPr lang="en-US" sz="1650" dirty="0"/>
+            <a:endParaRPr lang="en-US" sz="1600" dirty="0"/>
           </a:p>
         </p:txBody>
       </p:sp>
@@ -24441,7 +24441,7 @@
         </p:nvSpPr>
         <p:spPr>
           <a:xfrm>
-            <a:off x="914400" y="6108192"/>
+            <a:off x="914400" y="6236208"/>
             <a:ext cx="10332720" cy="320040"/>
           </a:xfrm>
           <a:prstGeom prst="rect">
@@ -29503,12 +29503,12 @@
         </p:nvSpPr>
         <p:spPr>
           <a:xfrm>
-            <a:off x="502920" y="3310128"/>
-            <a:ext cx="5440680" cy="2395728"/>
+            <a:off x="502920" y="3273552"/>
+            <a:ext cx="5440680" cy="2542032"/>
           </a:xfrm>
           <a:prstGeom prst="roundRect">
             <a:avLst>
-              <a:gd name="adj" fmla="val 3053"/>
+              <a:gd name="adj" fmla="val 2878"/>
             </a:avLst>
           </a:prstGeom>
           <a:solidFill>
@@ -29525,7 +29525,7 @@
         </p:nvSpPr>
         <p:spPr>
           <a:xfrm>
-            <a:off x="777240" y="3456432"/>
+            <a:off x="777240" y="3401568"/>
             <a:ext cx="4937760" cy="329184"/>
           </a:xfrm>
           <a:prstGeom prst="rect">
@@ -29564,8 +29564,8 @@
         </p:nvSpPr>
         <p:spPr>
           <a:xfrm>
-            <a:off x="777240" y="3822192"/>
-            <a:ext cx="4937760" cy="1828800"/>
+            <a:off x="777240" y="3785616"/>
+            <a:ext cx="4937760" cy="1883664"/>
           </a:xfrm>
           <a:prstGeom prst="rect">
             <a:avLst/>
@@ -29579,16 +29579,16 @@
           <a:p>
             <a:pPr marL="342900" indent="-342900">
               <a:lnSpc>
-                <a:spcPts val="1900"/>
+                <a:spcPts val="1800"/>
               </a:lnSpc>
               <a:spcAft>
-                <a:spcPts val="900"/>
+                <a:spcPts val="800"/>
               </a:spcAft>
               <a:buSzPct val="100000"/>
               <a:buChar char="•"/>
             </a:pPr>
             <a:r>
-              <a:rPr lang="en-US" sz="1550" dirty="0">
+              <a:rPr lang="en-US" sz="1500" dirty="0">
                 <a:solidFill>
                   <a:srgbClr val="1A1A1A"/>
                 </a:solidFill>
@@ -29598,21 +29598,21 @@
               </a:rPr>
               <a:t>Blood-collection tubes leave EDTA peaks that can dominate a spectrum and swamp the row normalisation.</a:t>
             </a:r>
-            <a:endParaRPr lang="en-US" sz="1550" dirty="0"/>
+            <a:endParaRPr lang="en-US" sz="1500" dirty="0"/>
           </a:p>
           <a:p>
             <a:pPr marL="342900" indent="-342900">
               <a:lnSpc>
-                <a:spcPts val="1900"/>
+                <a:spcPts val="1800"/>
               </a:lnSpc>
               <a:spcAft>
-                <a:spcPts val="900"/>
+                <a:spcPts val="800"/>
               </a:spcAft>
               <a:buSzPct val="100000"/>
               <a:buChar char="•"/>
             </a:pPr>
             <a:r>
-              <a:rPr lang="en-US" sz="1550" dirty="0">
+              <a:rPr lang="en-US" sz="1500" dirty="0">
                 <a:solidFill>
                   <a:srgbClr val="1A1A1A"/>
                 </a:solidFill>
@@ -29622,21 +29622,21 @@
               </a:rPr>
               <a:t>v3 → v4 fixed a genuine cutoff bug: the suppression was removing too much of the surrounding signal.</a:t>
             </a:r>
-            <a:endParaRPr lang="en-US" sz="1550" dirty="0"/>
+            <a:endParaRPr lang="en-US" sz="1500" dirty="0"/>
           </a:p>
           <a:p>
             <a:pPr marL="342900" indent="-342900">
               <a:lnSpc>
-                <a:spcPts val="1900"/>
+                <a:spcPts val="1800"/>
               </a:lnSpc>
               <a:spcAft>
-                <a:spcPts val="900"/>
+                <a:spcPts val="800"/>
               </a:spcAft>
               <a:buSzPct val="100000"/>
               <a:buChar char="•"/>
             </a:pPr>
             <a:r>
-              <a:rPr lang="en-US" sz="1550" dirty="0">
+              <a:rPr lang="en-US" sz="1500" dirty="0">
                 <a:solidFill>
                   <a:srgbClr val="1A1A1A"/>
                 </a:solidFill>
@@ -29646,7 +29646,7 @@
               </a:rPr>
               <a:t>7 rows repo-wide still retain a dominant EDTA peak — documented, not hidden.</a:t>
             </a:r>
-            <a:endParaRPr lang="en-US" sz="1550" dirty="0"/>
+            <a:endParaRPr lang="en-US" sz="1500" dirty="0"/>
           </a:p>
         </p:txBody>
       </p:sp>
@@ -29658,12 +29658,12 @@
         </p:nvSpPr>
         <p:spPr>
           <a:xfrm>
-            <a:off x="6217920" y="3310128"/>
-            <a:ext cx="5440680" cy="2395728"/>
+            <a:off x="6217920" y="3273552"/>
+            <a:ext cx="5440680" cy="2542032"/>
           </a:xfrm>
           <a:prstGeom prst="roundRect">
             <a:avLst>
-              <a:gd name="adj" fmla="val 3053"/>
+              <a:gd name="adj" fmla="val 2878"/>
             </a:avLst>
           </a:prstGeom>
           <a:solidFill>
@@ -29680,7 +29680,7 @@
         </p:nvSpPr>
         <p:spPr>
           <a:xfrm>
-            <a:off x="6492240" y="3456432"/>
+            <a:off x="6492240" y="3401568"/>
             <a:ext cx="4937760" cy="365760"/>
           </a:xfrm>
           <a:prstGeom prst="rect">
@@ -29719,8 +29719,8 @@
         </p:nvSpPr>
         <p:spPr>
           <a:xfrm>
-            <a:off x="6492240" y="3913632"/>
-            <a:ext cx="4937760" cy="1737360"/>
+            <a:off x="6492240" y="3785616"/>
+            <a:ext cx="4937760" cy="1883664"/>
           </a:xfrm>
           <a:prstGeom prst="rect">
             <a:avLst/>
@@ -31544,8 +31544,8 @@
         </p:blipFill>
         <p:spPr>
           <a:xfrm>
-            <a:off x="1051651" y="1371600"/>
-            <a:ext cx="10058217" cy="3703320"/>
+            <a:off x="1051638" y="1371600"/>
+            <a:ext cx="10058245" cy="3931920"/>
           </a:xfrm>
           <a:prstGeom prst="rect">
             <a:avLst/>
@@ -31560,8 +31560,8 @@
         </p:nvSpPr>
         <p:spPr>
           <a:xfrm>
-            <a:off x="502920" y="5138928"/>
-            <a:ext cx="11155680" cy="292608"/>
+            <a:off x="502920" y="5340096"/>
+            <a:ext cx="11155680" cy="274320"/>
           </a:xfrm>
           <a:prstGeom prst="rect">
             <a:avLst/>
@@ -31615,20 +31615,6 @@
               </a:rPr>
               <a:t>  on the hidden bins only</a:t>
             </a:r>
-            <a:pPr algn="ctr" indent="0" marL="0">
-              <a:buNone/>
-            </a:pPr>
-            <a:r>
-              <a:rPr lang="en-US" sz="1500" i="1" dirty="0">
-                <a:solidFill>
-                  <a:srgbClr val="5A6068"/>
-                </a:solidFill>
-                <a:latin typeface="Arial" pitchFamily="34" charset="0"/>
-                <a:ea typeface="Arial" pitchFamily="34" charset="-122"/>
-                <a:cs typeface="Arial" pitchFamily="34" charset="-120"/>
-              </a:rPr>
-              <a:t>     (whole-spectrum r = 0.979 — but that includes the 75% of bins the model was given)</a:t>
-            </a:r>
             <a:endParaRPr lang="en-US" sz="1500" dirty="0"/>
           </a:p>
         </p:txBody>
@@ -31641,12 +31627,12 @@
         </p:nvSpPr>
         <p:spPr>
           <a:xfrm>
-            <a:off x="502920" y="5541264"/>
-            <a:ext cx="11155680" cy="859536"/>
+            <a:off x="502920" y="5669280"/>
+            <a:ext cx="11155680" cy="731520"/>
           </a:xfrm>
           <a:prstGeom prst="roundRect">
             <a:avLst>
-              <a:gd name="adj" fmla="val 8511"/>
+              <a:gd name="adj" fmla="val 10000"/>
             </a:avLst>
           </a:prstGeom>
           <a:solidFill>
@@ -31663,8 +31649,8 @@
         </p:nvSpPr>
         <p:spPr>
           <a:xfrm>
-            <a:off x="777240" y="5605272"/>
-            <a:ext cx="10607040" cy="731520"/>
+            <a:off x="777240" y="5705856"/>
+            <a:ext cx="10607040" cy="658368"/>
           </a:xfrm>
           <a:prstGeom prst="rect">
             <a:avLst/>
@@ -31678,12 +31664,12 @@
           <a:p>
             <a:pPr indent="0" marL="0">
               <a:lnSpc>
-                <a:spcPts val="1900"/>
+                <a:spcPts val="1800"/>
               </a:lnSpc>
               <a:buNone/>
             </a:pPr>
             <a:r>
-              <a:rPr lang="en-US" sz="1550" b="1" dirty="0">
+              <a:rPr lang="en-US" sz="1500" b="1" dirty="0">
                 <a:solidFill>
                   <a:srgbClr val="C1435B"/>
                 </a:solidFill>
@@ -31695,12 +31681,12 @@
             </a:r>
             <a:pPr indent="0" marL="0">
               <a:lnSpc>
-                <a:spcPts val="1900"/>
+                <a:spcPts val="1800"/>
               </a:lnSpc>
               <a:buNone/>
             </a:pPr>
             <a:r>
-              <a:rPr lang="en-US" sz="1550" dirty="0">
+              <a:rPr lang="en-US" sz="1500" dirty="0">
                 <a:solidFill>
                   <a:srgbClr val="1A1A1A"/>
                 </a:solidFill>
@@ -31708,9 +31694,9 @@
                 <a:ea typeface="Arial" pitchFamily="34" charset="-122"/>
                 <a:cs typeface="Arial" pitchFamily="34" charset="-120"/>
               </a:rPr>
-              <a:t>the pretext task is genuinely solved well — and it still tells you almost nothing. Across five backbones, BETTER reconstruction went with WORSE transfer; our 2.3×-better-reconstructing model transferred 0.06 worse. So we never select a checkpoint, architecture or epoch on reconstruction loss.</a:t>
-            </a:r>
-            <a:endParaRPr lang="en-US" sz="1550" dirty="0"/>
+              <a:t>the pretext task is genuinely solved well — and it still tells you almost nothing. (February's r = 0.999 was whole-spectrum, which includes the 75% of bins the model is handed.) Across five backbones BETTER reconstruction went with WORSE transfer, so we never select a checkpoint, architecture or epoch on reconstruction loss.</a:t>
+            </a:r>
+            <a:endParaRPr lang="en-US" sz="1500" dirty="0"/>
           </a:p>
         </p:txBody>
       </p:sp>

</xml_diff>

<commit_message>
Last two QA items: slide 19 annotation lanes, slide 29 bottom margin
Spread gm04's two corpus groups apart (centres 0 and 1.45) so the v3 mean/sd
caption no longer abuts the v4 shaded band and the pointer text clears the v4
outlier point. Lift slide 29's footer to a 0.47in bottom margin.

Deck now verified clean on all 29 slides.

Co-Authored-By: Claude Opus 5 <noreply@anthropic.com>
</commit_message>
<xml_diff>
--- a/docs/Group_Meeting_2026-08-10.pptx
+++ b/docs/Group_Meeting_2026-08-10.pptx
@@ -24441,8 +24441,8 @@
         </p:nvSpPr>
         <p:spPr>
           <a:xfrm>
-            <a:off x="914400" y="6236208"/>
-            <a:ext cx="10332720" cy="320040"/>
+            <a:off x="914400" y="6126480"/>
+            <a:ext cx="10332720" cy="292608"/>
           </a:xfrm>
           <a:prstGeom prst="rect">
             <a:avLst/>

</xml_diff>